<commit_message>
finalizing docs and ppt
</commit_message>
<xml_diff>
--- a/docs/LearnIT-Pitch-Deck.pptx
+++ b/docs/LearnIT-Pitch-Deck.pptx
@@ -1394,7 +1394,7 @@
           <a:p>
             <a:r>
               <a:rPr lang="en-US" dirty="0"/>
-              <a:t>This is the money-shot slide. Cut to the live app here. Lead with the Guide/Briefing/Quiz payoff on a pre-built topic; never wait on live generation.</a:t>
+              <a:t>This is the money-shot slide. Cut to the live app here. Lead with the Guide/Briefing/Quiz payoff on a pre-built topic; never wait on live generation. Judges can scan the QR to open it on their own phones.</a:t>
             </a:r>
             <a:endParaRPr lang="en-US" dirty="0"/>
           </a:p>
@@ -1976,7 +1976,7 @@
                 <a:ea typeface="Courier New" pitchFamily="34" charset="-122"/>
                 <a:cs typeface="Courier New" pitchFamily="34" charset="-120"/>
               </a:rPr>
-              <a:t>TEAM · [TEAM NAME]</a:t>
+              <a:t>TEAM · TEAMPURA · ABBA</a:t>
             </a:r>
             <a:endParaRPr lang="en-US" sz="1050" dirty="0"/>
           </a:p>
@@ -2015,7 +2015,7 @@
                 <a:ea typeface="Courier New" pitchFamily="34" charset="-122"/>
                 <a:cs typeface="Courier New" pitchFamily="34" charset="-120"/>
               </a:rPr>
-              <a:t>[HACKATHON · DATE]</a:t>
+              <a:t>HACKATHON · 09.04.2026</a:t>
             </a:r>
             <a:endParaRPr lang="en-US" sz="1050" dirty="0"/>
           </a:p>
@@ -5167,7 +5167,7 @@
                 <a:ea typeface="Courier New" pitchFamily="34" charset="-122"/>
                 <a:cs typeface="Courier New" pitchFamily="34" charset="-120"/>
               </a:rPr>
-              <a:t>[TEAM NAME] · ABBA</a:t>
+              <a:t>TEAMPURA · ABBA</a:t>
             </a:r>
             <a:endParaRPr lang="en-US" sz="1050" dirty="0"/>
           </a:p>
@@ -5182,7 +5182,7 @@
         <p:spPr>
           <a:xfrm>
             <a:off x="548640" y="2103120"/>
-            <a:ext cx="10972800" cy="2194560"/>
+            <a:ext cx="7498080" cy="2194560"/>
           </a:xfrm>
           <a:prstGeom prst="rect">
             <a:avLst/>
@@ -5270,6 +5270,91 @@
       <p:sp>
         <p:nvSpPr>
           <p:cNvPr id="5" name="Shape 3"/>
+          <p:cNvSpPr/>
+          <p:nvPr/>
+        </p:nvSpPr>
+        <p:spPr>
+          <a:xfrm>
+            <a:off x="9720072" y="1673352"/>
+            <a:ext cx="1956816" cy="1956816"/>
+          </a:xfrm>
+          <a:prstGeom prst="roundRect">
+            <a:avLst>
+              <a:gd name="adj" fmla="val 2804"/>
+            </a:avLst>
+          </a:prstGeom>
+          <a:solidFill>
+            <a:srgbClr val="FFFFFF"/>
+          </a:solidFill>
+          <a:ln/>
+        </p:spPr>
+      </p:sp>
+      <p:pic>
+        <p:nvPicPr>
+          <p:cNvPr id="6" name="Image 0" descr="/tmp/claude-0/-home-claude/cae48e73-1371-52af-ade0-d49b214bf70b/scratchpad/qr.png">    </p:cNvPr>
+          <p:cNvPicPr>
+            <a:picLocks noChangeAspect="1"/>
+          </p:cNvPicPr>
+          <p:nvPr/>
+        </p:nvPicPr>
+        <p:blipFill>
+          <a:blip r:embed="rId1"/>
+          <a:stretch>
+            <a:fillRect/>
+          </a:stretch>
+        </p:blipFill>
+        <p:spPr>
+          <a:xfrm>
+            <a:off x="9829800" y="1783080"/>
+            <a:ext cx="1737360" cy="1737360"/>
+          </a:xfrm>
+          <a:prstGeom prst="rect">
+            <a:avLst/>
+          </a:prstGeom>
+        </p:spPr>
+      </p:pic>
+      <p:sp>
+        <p:nvSpPr>
+          <p:cNvPr id="7" name="Text 4"/>
+          <p:cNvSpPr txBox="1"/>
+          <p:nvPr/>
+        </p:nvSpPr>
+        <p:spPr>
+          <a:xfrm>
+            <a:off x="9098280" y="3703320"/>
+            <a:ext cx="3108960" cy="274320"/>
+          </a:xfrm>
+          <a:prstGeom prst="rect">
+            <a:avLst/>
+          </a:prstGeom>
+          <a:noFill/>
+          <a:ln/>
+        </p:spPr>
+        <p:txBody>
+          <a:bodyPr wrap="square" lIns="0" tIns="0" rIns="0" bIns="0" rtlCol="0" anchor="ctr"/>
+          <a:lstStyle/>
+          <a:p>
+            <a:pPr algn="ctr" indent="0" marL="0">
+              <a:buNone/>
+            </a:pPr>
+            <a:r>
+              <a:rPr lang="en-US" sz="1200" spc="140" kern="0" dirty="0">
+                <a:solidFill>
+                  <a:srgbClr val="C3EDA1"/>
+                </a:solidFill>
+                <a:latin typeface="Courier New" pitchFamily="34" charset="0"/>
+                <a:ea typeface="Courier New" pitchFamily="34" charset="-122"/>
+                <a:cs typeface="Courier New" pitchFamily="34" charset="-120"/>
+              </a:rPr>
+              <a:t>SCAN TO TRY IT LIVE</a:t>
+            </a:r>
+            <a:endParaRPr lang="en-US" sz="1200" dirty="0"/>
+          </a:p>
+        </p:txBody>
+      </p:sp>
+      <p:sp>
+        <p:nvSpPr>
+          <p:cNvPr id="8" name="Shape 5"/>
           <p:cNvSpPr/>
           <p:nvPr/>
         </p:nvSpPr>
@@ -5292,7 +5377,7 @@
       </p:sp>
       <p:sp>
         <p:nvSpPr>
-          <p:cNvPr id="6" name="Text 4"/>
+          <p:cNvPr id="9" name="Text 6"/>
           <p:cNvSpPr txBox="1"/>
           <p:nvPr/>
         </p:nvSpPr>
@@ -5331,7 +5416,7 @@
       </p:sp>
       <p:sp>
         <p:nvSpPr>
-          <p:cNvPr id="7" name="Text 5"/>
+          <p:cNvPr id="10" name="Text 7"/>
           <p:cNvSpPr txBox="1"/>
           <p:nvPr/>
         </p:nvSpPr>
@@ -5370,7 +5455,7 @@
       </p:sp>
       <p:sp>
         <p:nvSpPr>
-          <p:cNvPr id="8" name="Text 6"/>
+          <p:cNvPr id="11" name="Text 8"/>
           <p:cNvSpPr txBox="1"/>
           <p:nvPr/>
         </p:nvSpPr>
@@ -5409,7 +5494,7 @@
       </p:sp>
       <p:sp>
         <p:nvSpPr>
-          <p:cNvPr id="9" name="Text 7"/>
+          <p:cNvPr id="12" name="Text 9"/>
           <p:cNvSpPr txBox="1"/>
           <p:nvPr/>
         </p:nvSpPr>
@@ -5448,7 +5533,7 @@
       </p:sp>
       <p:sp>
         <p:nvSpPr>
-          <p:cNvPr id="10" name="Text 8"/>
+          <p:cNvPr id="13" name="Text 10"/>
           <p:cNvSpPr txBox="1"/>
           <p:nvPr/>
         </p:nvSpPr>
@@ -5487,7 +5572,7 @@
       </p:sp>
       <p:sp>
         <p:nvSpPr>
-          <p:cNvPr id="11" name="Text 9"/>
+          <p:cNvPr id="14" name="Text 11"/>
           <p:cNvSpPr txBox="1"/>
           <p:nvPr/>
         </p:nvSpPr>
@@ -5526,7 +5611,7 @@
       </p:sp>
       <p:sp>
         <p:nvSpPr>
-          <p:cNvPr id="12" name="Text 10"/>
+          <p:cNvPr id="15" name="Text 12"/>
           <p:cNvSpPr txBox="1"/>
           <p:nvPr/>
         </p:nvSpPr>
@@ -11048,7 +11133,7 @@
         </p:nvSpPr>
         <p:spPr>
           <a:xfrm>
-            <a:off x="7772400" y="3108960"/>
+            <a:off x="7772400" y="3063240"/>
             <a:ext cx="384048" cy="384048"/>
           </a:xfrm>
           <a:prstGeom prst="ellipse">
@@ -11073,7 +11158,7 @@
         </p:nvSpPr>
         <p:spPr>
           <a:xfrm>
-            <a:off x="7772400" y="3108960"/>
+            <a:off x="7772400" y="3063240"/>
             <a:ext cx="384048" cy="384048"/>
           </a:xfrm>
           <a:prstGeom prst="rect">
@@ -11112,7 +11197,7 @@
         </p:nvSpPr>
         <p:spPr>
           <a:xfrm>
-            <a:off x="8275320" y="3063240"/>
+            <a:off x="8275320" y="3017520"/>
             <a:ext cx="3291840" cy="292608"/>
           </a:xfrm>
           <a:prstGeom prst="rect">
@@ -11151,7 +11236,7 @@
         </p:nvSpPr>
         <p:spPr>
           <a:xfrm>
-            <a:off x="8275320" y="3355848"/>
+            <a:off x="8275320" y="3310128"/>
             <a:ext cx="3383280" cy="365760"/>
           </a:xfrm>
           <a:prstGeom prst="rect">
@@ -11190,7 +11275,7 @@
         </p:nvSpPr>
         <p:spPr>
           <a:xfrm>
-            <a:off x="7772400" y="3886200"/>
+            <a:off x="7772400" y="3566160"/>
             <a:ext cx="384048" cy="384048"/>
           </a:xfrm>
           <a:prstGeom prst="ellipse">
@@ -11215,7 +11300,7 @@
         </p:nvSpPr>
         <p:spPr>
           <a:xfrm>
-            <a:off x="7772400" y="3886200"/>
+            <a:off x="7772400" y="3566160"/>
             <a:ext cx="384048" cy="384048"/>
           </a:xfrm>
           <a:prstGeom prst="rect">
@@ -11254,7 +11339,7 @@
         </p:nvSpPr>
         <p:spPr>
           <a:xfrm>
-            <a:off x="8275320" y="3840480"/>
+            <a:off x="8275320" y="3520440"/>
             <a:ext cx="3291840" cy="292608"/>
           </a:xfrm>
           <a:prstGeom prst="rect">
@@ -11293,7 +11378,7 @@
         </p:nvSpPr>
         <p:spPr>
           <a:xfrm>
-            <a:off x="8275320" y="4133088"/>
+            <a:off x="8275320" y="3813048"/>
             <a:ext cx="3383280" cy="365760"/>
           </a:xfrm>
           <a:prstGeom prst="rect">
@@ -11332,7 +11417,7 @@
         </p:nvSpPr>
         <p:spPr>
           <a:xfrm>
-            <a:off x="7772400" y="4663440"/>
+            <a:off x="7772400" y="4069080"/>
             <a:ext cx="384048" cy="384048"/>
           </a:xfrm>
           <a:prstGeom prst="ellipse">
@@ -11357,7 +11442,7 @@
         </p:nvSpPr>
         <p:spPr>
           <a:xfrm>
-            <a:off x="7772400" y="4663440"/>
+            <a:off x="7772400" y="4069080"/>
             <a:ext cx="384048" cy="384048"/>
           </a:xfrm>
           <a:prstGeom prst="rect">
@@ -11396,7 +11481,7 @@
         </p:nvSpPr>
         <p:spPr>
           <a:xfrm>
-            <a:off x="8275320" y="4617720"/>
+            <a:off x="8275320" y="4023360"/>
             <a:ext cx="3291840" cy="292608"/>
           </a:xfrm>
           <a:prstGeom prst="rect">
@@ -11435,7 +11520,7 @@
         </p:nvSpPr>
         <p:spPr>
           <a:xfrm>
-            <a:off x="8275320" y="4910328"/>
+            <a:off x="8275320" y="4315968"/>
             <a:ext cx="3383280" cy="365760"/>
           </a:xfrm>
           <a:prstGeom prst="rect">
@@ -11474,7 +11559,7 @@
         </p:nvSpPr>
         <p:spPr>
           <a:xfrm>
-            <a:off x="7772400" y="5440680"/>
+            <a:off x="7772400" y="4572000"/>
             <a:ext cx="384048" cy="384048"/>
           </a:xfrm>
           <a:prstGeom prst="ellipse">
@@ -11499,7 +11584,7 @@
         </p:nvSpPr>
         <p:spPr>
           <a:xfrm>
-            <a:off x="7772400" y="5440680"/>
+            <a:off x="7772400" y="4572000"/>
             <a:ext cx="384048" cy="384048"/>
           </a:xfrm>
           <a:prstGeom prst="rect">
@@ -11538,7 +11623,7 @@
         </p:nvSpPr>
         <p:spPr>
           <a:xfrm>
-            <a:off x="8275320" y="5394960"/>
+            <a:off x="8275320" y="4526280"/>
             <a:ext cx="3291840" cy="292608"/>
           </a:xfrm>
           <a:prstGeom prst="rect">
@@ -11577,7 +11662,7 @@
         </p:nvSpPr>
         <p:spPr>
           <a:xfrm>
-            <a:off x="8275320" y="5687568"/>
+            <a:off x="8275320" y="4818888"/>
             <a:ext cx="3383280" cy="365760"/>
           </a:xfrm>
           <a:prstGeom prst="rect">
@@ -11603,6 +11688,133 @@
                 <a:cs typeface="Calibri" pitchFamily="34" charset="-120"/>
               </a:rPr>
               <a:t>Bot replies, then digests it back to you.</a:t>
+            </a:r>
+            <a:endParaRPr lang="en-US" sz="1100" dirty="0"/>
+          </a:p>
+        </p:txBody>
+      </p:sp>
+      <p:sp>
+        <p:nvSpPr>
+          <p:cNvPr id="41" name="Shape 39"/>
+          <p:cNvSpPr/>
+          <p:nvPr/>
+        </p:nvSpPr>
+        <p:spPr>
+          <a:xfrm>
+            <a:off x="10177272" y="5148072"/>
+            <a:ext cx="1453896" cy="1453896"/>
+          </a:xfrm>
+          <a:prstGeom prst="roundRect">
+            <a:avLst>
+              <a:gd name="adj" fmla="val 3774"/>
+            </a:avLst>
+          </a:prstGeom>
+          <a:solidFill>
+            <a:srgbClr val="FFFFFF"/>
+          </a:solidFill>
+          <a:ln/>
+        </p:spPr>
+      </p:sp>
+      <p:pic>
+        <p:nvPicPr>
+          <p:cNvPr id="42" name="Image 0" descr="/tmp/claude-0/-home-claude/cae48e73-1371-52af-ade0-d49b214bf70b/scratchpad/qr.png">    </p:cNvPr>
+          <p:cNvPicPr>
+            <a:picLocks noChangeAspect="1"/>
+          </p:cNvPicPr>
+          <p:nvPr/>
+        </p:nvPicPr>
+        <p:blipFill>
+          <a:blip r:embed="rId1"/>
+          <a:stretch>
+            <a:fillRect/>
+          </a:stretch>
+        </p:blipFill>
+        <p:spPr>
+          <a:xfrm>
+            <a:off x="10287000" y="5257800"/>
+            <a:ext cx="1234440" cy="1234440"/>
+          </a:xfrm>
+          <a:prstGeom prst="rect">
+            <a:avLst/>
+          </a:prstGeom>
+        </p:spPr>
+      </p:pic>
+      <p:sp>
+        <p:nvSpPr>
+          <p:cNvPr id="43" name="Text 40"/>
+          <p:cNvSpPr txBox="1"/>
+          <p:nvPr/>
+        </p:nvSpPr>
+        <p:spPr>
+          <a:xfrm>
+            <a:off x="7863840" y="5486400"/>
+            <a:ext cx="2286000" cy="274320"/>
+          </a:xfrm>
+          <a:prstGeom prst="rect">
+            <a:avLst/>
+          </a:prstGeom>
+          <a:noFill/>
+          <a:ln/>
+        </p:spPr>
+        <p:txBody>
+          <a:bodyPr wrap="square" lIns="0" tIns="0" rIns="0" bIns="0" rtlCol="0" anchor="ctr"/>
+          <a:lstStyle/>
+          <a:p>
+            <a:pPr algn="l" indent="0" marL="0">
+              <a:buNone/>
+            </a:pPr>
+            <a:r>
+              <a:rPr lang="en-US" sz="1200" spc="120" kern="0" dirty="0">
+                <a:solidFill>
+                  <a:srgbClr val="C3EDA1"/>
+                </a:solidFill>
+                <a:latin typeface="Courier New" pitchFamily="34" charset="0"/>
+                <a:ea typeface="Courier New" pitchFamily="34" charset="-122"/>
+                <a:cs typeface="Courier New" pitchFamily="34" charset="-120"/>
+              </a:rPr>
+              <a:t>SCAN TO TRY</a:t>
+            </a:r>
+            <a:endParaRPr lang="en-US" sz="1200" dirty="0"/>
+          </a:p>
+        </p:txBody>
+      </p:sp>
+      <p:sp>
+        <p:nvSpPr>
+          <p:cNvPr id="44" name="Text 41"/>
+          <p:cNvSpPr txBox="1"/>
+          <p:nvPr/>
+        </p:nvSpPr>
+        <p:spPr>
+          <a:xfrm>
+            <a:off x="7863840" y="5806440"/>
+            <a:ext cx="2286000" cy="548640"/>
+          </a:xfrm>
+          <a:prstGeom prst="rect">
+            <a:avLst/>
+          </a:prstGeom>
+          <a:noFill/>
+          <a:ln/>
+        </p:spPr>
+        <p:txBody>
+          <a:bodyPr wrap="square" lIns="0" tIns="0" rIns="0" bIns="0" rtlCol="0" anchor="ctr"/>
+          <a:lstStyle/>
+          <a:p>
+            <a:pPr algn="l" indent="0" marL="0">
+              <a:lnSpc>
+                <a:spcPts val="1400"/>
+              </a:lnSpc>
+              <a:buNone/>
+            </a:pPr>
+            <a:r>
+              <a:rPr lang="en-US" sz="1100" dirty="0">
+                <a:solidFill>
+                  <a:srgbClr val="A29C8E"/>
+                </a:solidFill>
+                <a:latin typeface="Calibri" pitchFamily="34" charset="0"/>
+                <a:ea typeface="Calibri" pitchFamily="34" charset="-122"/>
+                <a:cs typeface="Calibri" pitchFamily="34" charset="-120"/>
+              </a:rPr>
+              <a:t>Open it live on your phone</a:t>
             </a:r>
             <a:endParaRPr lang="en-US" sz="1100" dirty="0"/>
           </a:p>

</xml_diff>